<commit_message>
fix(windows11): select newly created LOT and release 0.1.72 documentation
</commit_message>
<xml_diff>
--- a/SmartM365/Devices/Windows11UpgradeToolkit/Windows11UpgradeToolkit-Procedure-EN.pptx
+++ b/SmartM365/Devices/Windows11UpgradeToolkit/Windows11UpgradeToolkit-Procedure-EN.pptx
@@ -11867,7 +11867,7 @@
                 <a:ea typeface="Calibri" pitchFamily="34" charset="-122"/>
                 <a:cs typeface="Calibri" pitchFamily="34" charset="-120"/>
               </a:rPr>
-              <a:t>Repository access (GitHub Desktop)</a:t>
+              <a:t>Verified operator ZIP</a:t>
             </a:r>
             <a:endParaRPr lang="en-US" sz="1250" dirty="0"/>
           </a:p>
@@ -11909,7 +11909,7 @@
                 <a:ea typeface="Calibri" pitchFamily="34" charset="-122"/>
                 <a:cs typeface="Calibri" pitchFamily="34" charset="-120"/>
               </a:rPr>
-              <a:t>Install GitHub Desktop, create an account if needed, sign in, then clone/sync https://github.com/khda79/workplacecloudhub.com locally, e.g. C:\WCH.</a:t>
+              <a:t>Download release 0.1.72, verify its SHA-256 using the README, then extract the complete ZIP to a new local folder. GitHub Desktop is optional.</a:t>
             </a:r>
             <a:endParaRPr lang="en-US" sz="1000" dirty="0"/>
           </a:p>
@@ -12078,7 +12078,7 @@
                 <a:ea typeface="Calibri" pitchFamily="34" charset="-122"/>
                 <a:cs typeface="Calibri" pitchFamily="34" charset="-120"/>
               </a:rPr>
-              <a:t>PowerShell 5.1 or 7+, access to the SmartM365 repository, permission to run LOTs.</a:t>
+              <a:t>WPF GUI: Windows PowerShell 5.1 / STA. LOT wrappers: PowerShell 7 preferred, with 5.1 fallback.</a:t>
             </a:r>
             <a:endParaRPr lang="en-US" sz="1000" dirty="0"/>
           </a:p>
@@ -12247,7 +12247,7 @@
                 <a:ea typeface="Calibri" pitchFamily="34" charset="-122"/>
                 <a:cs typeface="Calibri" pitchFamily="34" charset="-120"/>
               </a:rPr>
-              <a:t>PsExec.exe available under Scripts\ or %WINDIR%\System32, required for SYSTEM execution on targets.</a:t>
+              <a:t>Obtain PsExec.exe from Microsoft Sysinternals; place it in Scripts or on PATH for SYSTEM execution on targets.</a:t>
             </a:r>
             <a:endParaRPr lang="en-US" sz="1000" dirty="0"/>
           </a:p>
@@ -13584,7 +13584,7 @@
                 <a:ea typeface="Consolas" pitchFamily="34" charset="-122"/>
                 <a:cs typeface="Consolas" pitchFamily="34" charset="-120"/>
               </a:rPr>
-              <a:t>...LotLauncher-GUI.ps1  (WinForms/WPF GUI)</a:t>
+              <a:t>...LotLauncher-GUI.ps1  (WPF GUI)</a:t>
             </a:r>
             <a:endParaRPr lang="en-US" sz="1000" dirty="0"/>
           </a:p>

</xml_diff>